<commit_message>
fix theory about zod errormap
</commit_message>
<xml_diff>
--- a/src/slides/lesson-4-theory.pptx
+++ b/src/slides/lesson-4-theory.pptx
@@ -1174,9 +1174,9 @@
               <a:t>Speaker Notes:
 • These patterns might seem like extra work now
 • Pay dividends as application grows
-• Make code more predictable, testable, maintainable
-• Building habits for professional development
-• Foundation for scaling to larger teams
+• Prisma 8 migration workflow: emit → plan → migrate (replaces migrate dev/deploy)
+• Explicit join tables give you full control over many-to-many relations
+• TypeScript migrations are type-checked against your contract
 • Industry best practices</a:t>
             </a:r>
             <a:endParaRPr lang="en-US" dirty="0"/>
@@ -1547,7 +1547,27 @@
 • Controllers handle HTTP concerns, repositories handle data access
 • Makes code predictable and testable
 • TypeScript catches errors at compile time
-• Notice proper status codes and type conversions</a:t>
+• Notice proper status codes and type conversions
+---
+# Database Relations with Prisma 8
+Why this is usefull ? Strange pattern... putting paidExpenses and participatedExpenses in the User model...?
+What's the objective of this slide?
+```prisma
+// use prisma-8   ← required first line in every contract file
+model User {
+  id          Int     @id @default(autoincrement())
+  name        String
+  email       String  @unique
+  paidExpenses         Expense[] @relation("PayerExpenses")
+  participatedExpenses Expense[] @relation("ParticipantExpenses")
+  transfersOut         Transfer[] @relation("UserTransfersSource")
+  transfersIn          Transfer[] @relation("UserTransfersTarget")
+}
+```
+Speaker Notes:
+• Every contract file must start with "// use prisma-8"
+• Relation names still required when multiple relations between same models
+• One user has many relationships: pays, participates, sends, receives</a:t>
             </a:r>
             <a:endParaRPr lang="en-US" dirty="0"/>
           </a:p>
@@ -1636,11 +1656,10 @@
             <a:r>
               <a:rPr lang="en-US" dirty="0"/>
               <a:t>Speaker Notes:
-• Introducing proper relational data modeling
-• One user has many relationships: pays, participates, sends, receives
-• Relation names required when multiple relations between same models
-• Much better than storing comma-separated strings
-• Database enforces referential integrity</a:t>
+• Connection string and file paths live in prisma.config.ts
+• Import from @prisma/orm-postgres/config — this is what selects PostgreSQL
+• Run: npm install @prisma/orm-postgres
+• The contract key points at your contract.prisma file</a:t>
             </a:r>
             <a:endParaRPr lang="en-US" dirty="0"/>
           </a:p>
@@ -1730,10 +1749,10 @@
               <a:rPr lang="en-US" dirty="0"/>
               <a:t>Speaker Notes:
 • One expense has one payer but multiple participants
-• Prisma creates implicit join table for many-to-many relation
-• Much cleaner than storing comma-separated participant names
-• Database handles the complexity of relationships
-• Can query participants easily with include</a:t>
+• Prisma 8 requires an explicit join model — no more implicit many-to-many
+• ExpenseParticipant is the join table; its @@id must be exactly the two foreign keys
+• Relation names disambiguate: User has two relations to Expense
+• Query participants with .include("participants") — join model is transparent</a:t>
             </a:r>
             <a:endParaRPr lang="en-US" dirty="0"/>
           </a:p>
@@ -1822,12 +1841,12 @@
             <a:r>
               <a:rPr lang="en-US" dirty="0"/>
               <a:t>Speaker Notes:
-• Moving from db push to proper migrations
-• Migrations give version control for database schema
-• Can preserve data during schema changes
-• Ensures consistent deployments across environments
-• Dev creates and applies migrations, deploy only applies existing ones
-• Critical for production applications</a:t>
+• Three-step loop replaces migrate dev: emit → plan → migrate
+• prisma contract emit reads contract.prisma, writes contract.json + contract.d.ts
+• prisma migration plan generates a TypeScript migration.ts file to review
+• prisma db migrate applies pending migrations to the database
+• --advance-ref db records which contract state was applied (for dev)
+• No more db push — use db init (new DB) or db update (existing DB) instead</a:t>
             </a:r>
             <a:endParaRPr lang="en-US" dirty="0"/>
           </a:p>
@@ -1916,12 +1935,12 @@
             <a:r>
               <a:rPr lang="en-US" dirty="0"/>
               <a:t>Speaker Notes:
-• Sometimes need custom migration logic to preserve data
-• Converting string payers to User references
-• Create users from existing data first
-• Add foreign key column as nullable, populate it, then make required
-• Prevents data loss during schema evolution
-• SQL gives us fine control over migration process</a:t>
+• Prisma migrations are TypeScript files
+• migration plan auto-generates the skeleton with placeholders
+• dataTransform handles the backfill: check finds remaining rows, run fixes them
+• addColumn → dataTransform → setNotNull is the safe 3-step pattern for required cols
+• Edit migration.ts then recompile: node migrations/app/&lt;dir&gt;/migration.ts
+• Commit migration.ts, ops.json, migration.json, and snapshot dirs</a:t>
             </a:r>
             <a:endParaRPr lang="en-US" dirty="0"/>
           </a:p>

</xml_diff>